<commit_message>
Add live URLs (Vercel dashboard + EC2 API) to README and deck
Co-Authored-By: Claude Opus 4.8 <noreply@anthropic.com>
</commit_message>
<xml_diff>
--- a/docs/presentation.pptx
+++ b/docs/presentation.pptx
@@ -4260,7 +4260,7 @@
                 <a:ea typeface="Calibri" pitchFamily="34" charset="-122"/>
                 <a:cs typeface="Calibri" pitchFamily="34" charset="-120"/>
               </a:rPr>
-              <a:t>sensor-dashboard.vercel.app</a:t>
+              <a:t>sensor-dashboard-tan.vercel.app</a:t>
             </a:r>
             <a:endParaRPr lang="en-US" sz="1500" dirty="0"/>
           </a:p>
@@ -8546,7 +8546,7 @@
                 <a:ea typeface="Calibri" pitchFamily="34" charset="-122"/>
                 <a:cs typeface="Calibri" pitchFamily="34" charset="-120"/>
               </a:rPr>
-              <a:t>sensor-dashboard.vercel.app</a:t>
+              <a:t>sensor-dashboard-tan.vercel.app</a:t>
             </a:r>
             <a:endParaRPr lang="en-US" sz="1200" dirty="0"/>
           </a:p>

</xml_diff>